<commit_message>
Cite Park YW et al. (Korean J Radiol 2026, in press) as figure source; add vorasidenib approval dates
Co-Authored-By: Claude Opus 5.5 <noreply@anthropic.com>
Claude-Session: https://claude.ai/code/session_01PzFoykbWyEoGX1gUoZrhXb
</commit_message>
<xml_diff>
--- a/deck/cIMPACT-NOW_update12_disease_review.pptx
+++ b/deck/cIMPACT-NOW_update12_disease_review.pptx
@@ -604,7 +604,7 @@
 2) 없으면 mitotic count ≥3/2.4 mm²이면 grade 3, 아니면 grade 2.
 3) 주황 박스: grade 3를 시사하는 분자 변화 (CDK4/6, CCND2 amp, RB1, PIK3CA/PIK3R1, EGFR, MYCN, methylation A_IDH_HG/G-CIMP-low).
 4) Oligodendroglioma는 grading을 바꿀 근거가 없었다고 결론.
-※ 그림은 논문 Fig.를 기반으로 다시 그림.</a:t>
+※ 그림 출처: Park YW, ..., Park JE. Imaging of IDH-Mutant Gliomas in the Era of IDH Inhibitors: What Radiologists Need to Know. Korean J Radiol 2026 (in press) Fig. 2를 다시 그림. 기준 원문은 Brat 2026.</a:t>
             </a:r>
             <a:endParaRPr lang="en-US" dirty="0"/>
           </a:p>
@@ -881,7 +881,7 @@
               <a:rPr lang="en-US" dirty="0"/>
               <a:t>이 증례: 처음에는 조직학적으로 grade 3. 영상에서 ADC/CBV상 aggressive해 병리에 feedback → PDGFRA amplification 확인 → cIMPACT-NOW 12에 따라 grade 4로 재판독 → CCRT 시행.
 - Grade 3 IDH-mut astrocytoma: CATNON에서 adjuvant TMZ는 생존 이득 (IDH-mut에서 median OS 12.5 vs 6.0년, HR 0.54), concurrent TMZ는 유의한 이득 없음 (HR 0.81, NS).
-- Grade 2: INDIGO에서 vorasidenib이 PFS 27.7 vs 11.1개월로 개선 (잔존 non-enhancing grade 2 대상). Grade 4로 바뀌면 대상이 아님.
+- Grade 2: INDIGO에서 vorasidenib이 PFS 27.7 vs 11.1개월로 개선 (잔존 non-enhancing grade 2 대상). FDA 2024년 8월, 국내 식약처 2026년 1월 허가 (Park YW, KJR 2026). Grade 4로 바뀌면 대상이 아님.
 - Grade 4: 고등급 치료 (RT + TMZ).
 - 메시지: 영상의학과의 feedback이 molecular upgrade와 치료 변경으로 이어진 증례.</a:t>
             </a:r>
@@ -4495,7 +4495,7 @@
                 <a:ea typeface="Calibri" pitchFamily="34" charset="-122"/>
                 <a:cs typeface="Calibri" pitchFamily="34" charset="-120"/>
               </a:rPr>
-              <a:t>Adapted from Brat DJ et al. cIMPACT-NOW update 12. Neuro-Oncol 2026;28(9):2069-2089. doi:10.1093/neuonc/noag108</a:t>
+              <a:t>Figure: Park YW et al. Korean J Radiol 2026 (in press), Fig. 2 · Original criteria: Brat DJ et al. Neuro-Oncol 2026;28(9):2069-2089</a:t>
             </a:r>
             <a:endParaRPr lang="en-US" sz="900" dirty="0"/>
           </a:p>
@@ -6560,7 +6560,7 @@
                           <a:ea typeface="Calibri" pitchFamily="34" charset="-122"/>
                           <a:cs typeface="Calibri" pitchFamily="34" charset="-120"/>
                         </a:rPr>
-                        <a:t>관찰 (GTR) / 잔존 non-enhancing → vorasidenib (INDIGO)</a:t>
+                        <a:t>관찰 (GTR) / 잔존 non-enhancing → vorasidenib (INDIGO; 식약처 2026.1 허가)</a:t>
                       </a:r>
                       <a:endParaRPr lang="en-US" sz="1200" dirty="0">
                         <a:latin typeface="Calibri" charset="0"/>
@@ -7019,7 +7019,7 @@
                 <a:ea typeface="Calibri" pitchFamily="34" charset="-122"/>
                 <a:cs typeface="Calibri" pitchFamily="34" charset="-120"/>
               </a:rPr>
-              <a:t>van den Bent MJ, Lancet Oncol 2021;22:813 &amp; 2026;27:45 · Mellinghoff IK, NEJM 2023;389:589 · Weller M, Nat Rev Clin Oncol 2021;18:170 · Brat DJ, Neuro-Oncol 2026</a:t>
+              <a:t>van den Bent MJ, Lancet Oncol 2021;22:813 &amp; 2026;27:45 · Mellinghoff IK, NEJM 2023;389:589 · Weller M, Nat Rev Clin Oncol 2021;18:170 · Park YW, Korean J Radiol 2026 (in press)</a:t>
             </a:r>
             <a:endParaRPr lang="en-US" sz="900" dirty="0"/>
           </a:p>

</xml_diff>

<commit_message>
Translate deck to English; expand study note (cIMPACT-NOW 1-12, evidence critique, 24 adversarial Q&A)
Co-Authored-By: Claude Opus 5.5 <noreply@anthropic.com>
Claude-Session: https://claude.ai/code/session_01PzFoykbWyEoGX1gUoZrhXb
</commit_message>
<xml_diff>
--- a/deck/cIMPACT-NOW_update12_disease_review.pptx
+++ b/deck/cIMPACT-NOW_update12_disease_review.pptx
@@ -506,12 +506,12 @@
           <a:p>
             <a:r>
               <a:rPr lang="en-US" dirty="0"/>
-              <a:t>WHO CNS5 이후 나온 cIMPACT-NOW update를 짧게 정리.
-- Update 8: 수막종 grading. 1p del + 22q del/NF2 → grade 2 제안.
-- Update 9: methylation classifier 사용 원칙.
-- Update 10: 새 tumor type을 인정하는 기준. 기준 미충족 시 NEC로 보고.
-- Update 11: 40세 미만에서 EGFR amp나 +7/-10만으로 GBM 진단하지 말 것 (pediatric-type HGG 감별).
-- 오늘 핵심인 Update 12: IDH-mutant glioma grading 개정.</a:t>
+              <a:t>cIMPACT-NOW updates published after WHO CNS5.
+- Update 8: meningioma grading. 1p deletion with 22q deletion and/or NF2 variant upgrades a histologic grade 1 meningioma to grade 2.
+- Update 9: principles for using the DNA methylation classifier.
+- Update 10: criteria for accepting a new tumor type; tumors that do not meet them are reported as NEC.
+- Update 11: in patients under 40, EGFR amplification or +7/-10 alone should not establish GBM (consider pediatric-type HGG).
+- Update 12, today's focus: revised grading of IDH-mutant gliomas.</a:t>
             </a:r>
             <a:endParaRPr lang="en-US" dirty="0"/>
           </a:p>
@@ -600,11 +600,11 @@
             <a:r>
               <a:rPr lang="en-US" dirty="0"/>
               <a:t>Update 12 grading algorithm (Brat et al. 2026).
-1) MVP, necrosis, CDKN2A/B HD, 그리고 새로 PDGFRA amplification 중 하나라도 있으면 grade 4.
-2) 없으면 mitotic count ≥3/2.4 mm²이면 grade 3, 아니면 grade 2.
-3) 주황 박스: grade 3를 시사하는 분자 변화 (CDK4/6, CCND2 amp, RB1, PIK3CA/PIK3R1, EGFR, MYCN, methylation A_IDH_HG/G-CIMP-low).
-4) Oligodendroglioma는 grading을 바꿀 근거가 없었다고 결론.
-※ 그림 출처: Park YW, ..., Park JE. Imaging of IDH-Mutant Gliomas in the Era of IDH Inhibitors: What Radiologists Need to Know. Korean J Radiol 2026 (in press) Fig. 2를 다시 그림. 기준 원문은 Brat 2026.</a:t>
+1) Any of MVP, necrosis, CDKN2A/B HD or, newly, PDGFRA amplification → grade 4.
+2) Otherwise, mitotic count ≥3 per 2.4 mm² → grade 3; if not, grade 2.
+3) Orange box: molecular alterations that may suggest grade 3 (CDK4/6, CCND2 amp, RB1, PIK3CA/PIK3R1, EGFR, MYCN, methylation A_IDH_HG / G-CIMP-low).
+4) Oligodendroglioma: the working group found no new evidence to change grading.
+Figure redrawn from Park YW et al. Imaging of IDH-Mutant Gliomas in the Era of IDH Inhibitors: What Radiologists Need to Know. Korean J Radiol 2026 (in press), Fig. 2. Criteria from Brat et al. 2026.</a:t>
             </a:r>
             <a:endParaRPr lang="en-US" dirty="0"/>
           </a:p>
@@ -692,13 +692,13 @@
           <a:p>
             <a:r>
               <a:rPr lang="en-US" dirty="0"/>
-              <a:t>PDGFRA amplification이 grade 4 criterion이 된 근거.
-- Validation (Richardson 2026, 1,140명): PDGFRA amp으로 grade 4가 된 군의 median OS 51.4개월, grade 3 유지군은 126.2개월 (HR 1.9). Grade 2→4 7례, 3→4 15례.
-- Yang 2019 (160명, FISH): PDGFRA amp 18.8%, CDKN2A HD 15.0%, CDK4 amp 18.1%로 서로 겹치지 않음. 3 risk group의 mean OS 40.5/62.9/71.5개월.
-- CATNON (Tesileanu 2021): IDH-mut anaplastic astrocytoma 432명에서 PDGFRA amp는 독립 예후인자.
-- 실제 진료 (Tauziède-Espariat 2026): 50례 중 12례 (24%)에서 grade 변경, grade 3→4가 3례.
-- 검출: NGS, methylation array CNV, FISH 등. IHC를 screening에 쓰자는 보고 (Brain Pathol 2026).
-※ CATNON final analysis: PDGFRA amp는 예후 인자이지만 TMZ 효과의 predictive marker는 아님.</a:t>
+              <a:t>Why PDGFRA amplification became a grade 4 criterion.
+- Validation (Richardson 2026, n=1,140): tumors reclassified to grade 4 by PDGFRA amp had median OS 51.4 months vs 126.2 months for tumors that stayed grade 3 (HR 1.9). 7 cases moved from grade 2 to 4, 15 from grade 3 to 4.
+- Yang 2019 (n=160, FISH): PDGFRA amp 18.8%, CDKN2A HD 15.0%, CDK4 amp 18.1%, mutually exclusive. Mean OS of the three risk groups: 40.5 / 62.9 / 71.5 months.
+- CATNON (Tesileanu 2021): PDGFRA amp was an independent prognostic factor in 432 IDH-mutant anaplastic astrocytomas.
+- Routine practice (Tauziede-Espariat 2026): grade changed in 12 of 50 cases (24%), including 3 grade 3 → 4.
+- Detection: NGS, methylation-array CNV, FISH; IHC proposed as a screening tool (Brain Pathol 2026).
+Caveat: in the CATNON final analysis PDGFRA amp was prognostic but did not predict benefit from temozolomide.</a:t>
             </a:r>
             <a:endParaRPr lang="en-US" dirty="0"/>
           </a:p>
@@ -786,12 +786,12 @@
           <a:p>
             <a:r>
               <a:rPr lang="en-US" dirty="0"/>
-              <a:t>(증례 영상을 placeholder 자리에 넣어 주세요.)
-- T2-FLAIR mismatch: 특이도는 높지만 민감도는 낮음. ≥55세 cohort에서 grade 2의 25%에서만 보였고 grade 3/4에서는 없었음 (Alfattal 2026). CDKN2A HD 증례가 mismatch-negative와 연관 (Ozono 2026).
-- Enhancement 여부만으로 grade를 판단할 수 없음 (위 cohort에서 grade 2의 50%가 enhancement).
-- Non-enhancing glioma에서 rCBV는 grade 4 구분 AUC 0.718 (Imai 2025).
-- CDKN2A HD 예측: poorly defined enhancing margin (OR 13.19, Yang AJNR 2025).
-- PDGFRA amp에 특이적인 영상 소견은 아직 확립된 근거가 없음. 이 증례처럼 ADC/CBV가 조직 grade보다 aggressive하면 병리에 feedback을 주는 것이 핵심.</a:t>
+              <a:t>(Insert the case images into the placeholders.)
+- T2-FLAIR mismatch: high specificity, low sensitivity. In a cohort aged ≥55 it was seen in 25% of grade 2 and in no grade 3/4 tumors (Alfattal 2026). All CDKN2A HD cases were mismatch-negative (Ozono 2026).
+- Enhancement alone does not determine grade (50% of grade 2 tumors enhanced in that cohort).
+- In non-enhancing gliomas, rCBV discriminated grade 4 with AUC 0.718 (Imai 2025).
+- CDKN2A HD was predicted by a poorly defined enhancing margin (OR 13.19, Yang AJNR 2025).
+- No imaging feature specific to PDGFRA amplification has been established. When ADC/CBV look more aggressive than the histologic grade, as in this case, feed that back to pathology.</a:t>
             </a:r>
             <a:endParaRPr lang="en-US" dirty="0"/>
           </a:p>
@@ -879,11 +879,11 @@
           <a:p>
             <a:r>
               <a:rPr lang="en-US" dirty="0"/>
-              <a:t>이 증례: 처음에는 조직학적으로 grade 3. 영상에서 ADC/CBV상 aggressive해 병리에 feedback → PDGFRA amplification 확인 → cIMPACT-NOW 12에 따라 grade 4로 재판독 → CCRT 시행.
-- Grade 3 IDH-mut astrocytoma: CATNON에서 adjuvant TMZ는 생존 이득 (IDH-mut에서 median OS 12.5 vs 6.0년, HR 0.54), concurrent TMZ는 유의한 이득 없음 (HR 0.81, NS).
-- Grade 2: INDIGO에서 vorasidenib이 PFS 27.7 vs 11.1개월로 개선 (잔존 non-enhancing grade 2 대상). FDA 2024년 8월, 국내 식약처 2026년 1월 허가 (Park YW, KJR 2026). Grade 4로 바뀌면 대상이 아님.
-- Grade 4: 고등급 치료 (RT + TMZ).
-- 메시지: 영상의학과의 feedback이 molecular upgrade와 치료 변경으로 이어진 증례.</a:t>
+              <a:t>This case: histologic grade 3 at first. ADC and CBV looked aggressive, so we fed this back to pathology → PDGFRA amplification found → regraded to grade 4 under cIMPACT-NOW update 12 → concurrent chemoradiotherapy.
+- Grade 3 IDH-mut astrocytoma: in CATNON, adjuvant TMZ improved survival (IDH-mut median OS 12.5 vs 6.0 years, HR 0.54); concurrent TMZ did not reach significance (HR 0.81).
+- Grade 2: in INDIGO, vorasidenib improved PFS (27.7 vs 11.1 months) in residual non-enhancing grade 2 tumors. FDA approval Aug 2024, Korean MFDS Jan 2026 (Park YW, KJR 2026). A grade 4 tumor is not a candidate.
+- Grade 4 IDH-mut: ASCO-SNO 2022 says these patients may follow either the grade 3 astrocytoma or the IDH-wildtype GBM recommendations.
+- Message: radiology feedback led to a molecular upgrade and a change in treatment.</a:t>
             </a:r>
             <a:endParaRPr lang="en-US" dirty="0"/>
           </a:p>
@@ -1397,7 +1397,7 @@
                   <a:srgbClr val="FFC000"/>
                 </a:solidFill>
               </a:rPr>
-              <a:t>WHO CNS5 기준점  </a:t>
+              <a:t>WHO CNS5 baseline  </a:t>
             </a:r>
             <a:pPr indent="0" marL="0">
               <a:buNone/>
@@ -1408,7 +1408,7 @@
                   <a:srgbClr val="FFFFFF"/>
                 </a:solidFill>
               </a:rPr>
-              <a:t>Astrocytoma, IDH-mutant = 하나의 type, CNS WHO grade 2–4 / CDKN2A/B homozygous deletion → 조직 소견과 무관하게 grade 4</a:t>
+              <a:t>Astrocytoma, IDH-mutant = single tumor type, CNS WHO grade 2–4 / CDKN2A/B homozygous deletion → grade 4 regardless of histology</a:t>
             </a:r>
             <a:endParaRPr lang="en-US" sz="1300" dirty="0"/>
           </a:p>
@@ -1528,7 +1528,7 @@
                           <a:ea typeface="Calibri" pitchFamily="34" charset="-122"/>
                           <a:cs typeface="Calibri" pitchFamily="34" charset="-120"/>
                         </a:rPr>
-                        <a:t>발표</a:t>
+                        <a:t>Journal</a:t>
                       </a:r>
                       <a:endParaRPr lang="en-US" sz="1150" dirty="0">
                         <a:latin typeface="Calibri" charset="0"/>
@@ -1596,7 +1596,7 @@
                           <a:ea typeface="Calibri" pitchFamily="34" charset="-122"/>
                           <a:cs typeface="Calibri" pitchFamily="34" charset="-120"/>
                         </a:rPr>
-                        <a:t>대상</a:t>
+                        <a:t>Topic</a:t>
                       </a:r>
                       <a:endParaRPr lang="en-US" sz="1150" dirty="0">
                         <a:latin typeface="Calibri" charset="0"/>
@@ -1664,7 +1664,7 @@
                           <a:ea typeface="Calibri" pitchFamily="34" charset="-122"/>
                           <a:cs typeface="Calibri" pitchFamily="34" charset="-120"/>
                         </a:rPr>
-                        <a:t>핵심 내용</a:t>
+                        <a:t>Key recommendation</a:t>
                       </a:r>
                       <a:endParaRPr lang="en-US" sz="1150" dirty="0">
                         <a:latin typeface="Calibri" charset="0"/>
@@ -1938,7 +1938,7 @@
                           <a:ea typeface="Calibri" pitchFamily="34" charset="-122"/>
                           <a:cs typeface="Calibri" pitchFamily="34" charset="-120"/>
                         </a:rPr>
-                        <a:t>Grade 1 형태라도 1p deletion + 22q del and/or NF2 → grade 2 제안, brain invasion 판정 표준화</a:t>
+                        <a:t>Grade 1 histology + 1p deletion with 22q del and/or NF2 variant → grade 2; standardized brain invasion</a:t>
                       </a:r>
                       <a:endParaRPr lang="en-US" sz="1150" dirty="0">
                         <a:latin typeface="Calibri" charset="0"/>
@@ -2212,7 +2212,7 @@
                           <a:ea typeface="Calibri" pitchFamily="34" charset="-122"/>
                           <a:cs typeface="Calibri" pitchFamily="34" charset="-120"/>
                         </a:rPr>
-                        <a:t>Classifier는 integrated diagnosis의 한 도구 (단독 진단 X), layered report 작성 예시</a:t>
+                        <a:t>Classifier = one tool within integrated diagnosis (not stand-alone); layered report examples</a:t>
                       </a:r>
                       <a:endParaRPr lang="en-US" sz="1150" dirty="0">
                         <a:latin typeface="Calibri" charset="0"/>
@@ -2418,7 +2418,7 @@
                           <a:ea typeface="Calibri" pitchFamily="34" charset="-122"/>
                           <a:cs typeface="Calibri" pitchFamily="34" charset="-120"/>
                         </a:rPr>
-                        <a:t>New tumor type 정의</a:t>
+                        <a:t>Defining new tumor types</a:t>
                       </a:r>
                       <a:endParaRPr lang="en-US" sz="1150" dirty="0">
                         <a:latin typeface="Calibri" charset="0"/>
@@ -2486,7 +2486,7 @@
                           <a:ea typeface="Calibri" pitchFamily="34" charset="-122"/>
                           <a:cs typeface="Calibri" pitchFamily="34" charset="-120"/>
                         </a:rPr>
-                        <a:t>Clinical phenotype + methylation cluster + driver + histology, ≥2 독립 보고 → 미충족 시 NEC</a:t>
+                        <a:t>Clinical phenotype + methylation cluster + driver + histology, ≥2 independent reports; otherwise NEC</a:t>
                       </a:r>
                       <a:endParaRPr lang="en-US" sz="1150" dirty="0">
                         <a:latin typeface="Calibri" charset="0"/>
@@ -2760,7 +2760,7 @@
                           <a:ea typeface="Calibri" pitchFamily="34" charset="-122"/>
                           <a:cs typeface="Calibri" pitchFamily="34" charset="-120"/>
                         </a:rPr>
-                        <a:t>&lt;40세: EGFR amp·+7/−10 단독으로 GBM 진단 금지, TERTp 단독 저등급 → grade 4 신중</a:t>
+                        <a:t>Age &lt;40: EGFR amp or +7/−10 alone insufficient for GBM; caution with TERTp-only low-grade tumors</a:t>
                       </a:r>
                       <a:endParaRPr lang="en-US" sz="1150" dirty="0">
                         <a:latin typeface="Calibri" charset="0"/>
@@ -3034,7 +3034,7 @@
                           <a:ea typeface="Calibri" pitchFamily="34" charset="-122"/>
                           <a:cs typeface="Calibri" pitchFamily="34" charset="-120"/>
                         </a:rPr>
-                        <a:t>PDGFRA amp → grade 4, mitosis ≥3/2.4 mm² → grade 3, grade 3 분자 marker 제시</a:t>
+                        <a:t>PDGFRA amp → grade 4; mitoses ≥3/2.4 mm² → grade 3; molecular markers of grade 3</a:t>
                       </a:r>
                       <a:endParaRPr lang="en-US" sz="1150" dirty="0">
                         <a:latin typeface="Calibri" charset="0"/>
@@ -3131,7 +3131,7 @@
                   <a:srgbClr val="FFFFFF"/>
                 </a:solidFill>
               </a:rPr>
-              <a:t>은 WHO CNS5에 이미 반영됨 (예: update 3 molecular GBM, update 5 CDKN2A/B HD grading)</a:t>
+              <a:t> were incorporated into WHO CNS5 (e.g., update 3: molecular GBM; update 5: CDKN2A/B HD grading)</a:t>
             </a:r>
             <a:endParaRPr lang="en-US" sz="1200" dirty="0"/>
           </a:p>
@@ -4380,7 +4380,7 @@
                   <a:srgbClr val="BFBFBF"/>
                 </a:solidFill>
               </a:rPr>
-              <a:t>Oligodendroglioma: grading 개선 근거 없음 (기존 기준 유지)</a:t>
+              <a:t>Oligodendroglioma: no new grading criteria</a:t>
             </a:r>
             <a:endParaRPr lang="en-US" sz="1100" dirty="0"/>
           </a:p>
@@ -4420,7 +4420,7 @@
                   <a:srgbClr val="FFC000"/>
                 </a:solidFill>
               </a:rPr>
-              <a:t>Grade 4 criterion에 PDGFRA amplification 추가 (CDKN2A/B HD와 동급)</a:t>
+              <a:t>PDGFRA amplification added as a grade 4 criterion (same weight as CDKN2A/B HD)</a:t>
             </a:r>
             <a:endParaRPr lang="en-US" sz="1400" dirty="0"/>
           </a:p>
@@ -4438,7 +4438,7 @@
                   <a:srgbClr val="FFFFFF"/>
                 </a:solidFill>
               </a:rPr>
-              <a:t>Grade 2/3 경계: mitosis ≥3 / 2.4 mm² 수치 기준 제안, grade 3 분자 marker 명시</a:t>
+              <a:t>Grade 2 vs 3: numeric mitotic threshold (≥3 / 2.4 mm²) and molecular markers of grade 3</a:t>
             </a:r>
             <a:endParaRPr lang="en-US" sz="1400" dirty="0"/>
           </a:p>
@@ -4456,7 +4456,7 @@
                   <a:srgbClr val="FFFFFF"/>
                 </a:solidFill>
               </a:rPr>
-              <a:t>Histology grade 2/3여도 NGS · methylation CNV 결과로 upgrade 가능</a:t>
+              <a:t>Histologic grade 2/3 tumors can be upgraded by NGS or methylation-array CNV</a:t>
             </a:r>
             <a:endParaRPr lang="en-US" sz="1400" dirty="0"/>
           </a:p>
@@ -4660,7 +4660,7 @@
                   <a:srgbClr val="FFFFFF"/>
                 </a:solidFill>
               </a:rPr>
-              <a:t>Median OS: PDGFRA amp으로 grade 4 재분류 vs grade 3 유지 (HR 1.9, p=0.028)</a:t>
+              <a:t>Median OS: reclassified to grade 4 by PDGFRA amp vs remaining grade 3 (HR 1.9, p=0.028)</a:t>
             </a:r>
             <a:endParaRPr lang="en-US" sz="1150" dirty="0"/>
           </a:p>
@@ -4768,7 +4768,7 @@
                   <a:srgbClr val="FFFFFF"/>
                 </a:solidFill>
               </a:rPr>
-              <a:t>Grade 2/3 IDH-mut astrocytoma의 PDGFRA amp (FISH). CDKN2A HD · CDK4 amp와 mutually exclusive</a:t>
+              <a:t>PDGFRA amp in grade 2/3 IDH-mut astrocytoma (FISH); mutually exclusive with CDKN2A HD and CDK4 amp</a:t>
             </a:r>
             <a:endParaRPr lang="en-US" sz="1150" dirty="0"/>
           </a:p>
@@ -4876,7 +4876,7 @@
                   <a:srgbClr val="FFFFFF"/>
                 </a:solidFill>
               </a:rPr>
-              <a:t>실제 진료에서 molecular 결과로 grade 변경 (grade 3 → 4: 3례)</a:t>
+              <a:t>Grade changed by molecular results in routine practice (grade 3 → 4: 3 cases)</a:t>
             </a:r>
             <a:endParaRPr lang="en-US" sz="1150" dirty="0"/>
           </a:p>
@@ -4952,7 +4952,7 @@
                   <a:srgbClr val="FFC000"/>
                 </a:solidFill>
               </a:rPr>
-              <a:t>Update 12의 결론</a:t>
+              <a:t>Update 12 conclusion</a:t>
             </a:r>
             <a:endParaRPr lang="en-US" sz="1350" dirty="0"/>
           </a:p>
@@ -4988,7 +4988,7 @@
                   <a:srgbClr val="FFC000"/>
                 </a:solidFill>
               </a:rPr>
-              <a:t>근거</a:t>
+              <a:t>Evidence</a:t>
             </a:r>
             <a:endParaRPr lang="en-US" sz="1350" dirty="0"/>
           </a:p>
@@ -5006,7 +5006,7 @@
                   <a:srgbClr val="FFFFFF"/>
                 </a:solidFill>
               </a:rPr>
-              <a:t>Yang 2019: PDGFRA amp → 가장 나쁜 risk group (mean OS 40.5 vs 71.5 mo)</a:t>
+              <a:t>Yang 2019: PDGFRA amp = highest-risk group (mean OS 40.5 vs 71.5 mo)</a:t>
             </a:r>
             <a:endParaRPr lang="en-US" sz="1350" dirty="0"/>
           </a:p>
@@ -5024,7 +5024,7 @@
                   <a:srgbClr val="FFFFFF"/>
                 </a:solidFill>
               </a:rPr>
-              <a:t>CATNON (IDH-mut anaplastic astrocytoma 432명): 독립 예후인자</a:t>
+              <a:t>CATNON (432 IDH-mut anaplastic astrocytomas): independent prognostic factor</a:t>
             </a:r>
             <a:endParaRPr lang="en-US" sz="1350" dirty="0"/>
           </a:p>
@@ -5042,7 +5042,7 @@
                   <a:srgbClr val="FFFFFF"/>
                 </a:solidFill>
               </a:rPr>
-              <a:t>Virata 2026: 위 분자 변화가 있으면 grade 2/3의 median OS 67–82 mo vs 135–141 mo</a:t>
+              <a:t>Virata 2026: grade 2/3 with these alterations, median OS 67–82 vs 135–141 mo</a:t>
             </a:r>
             <a:endParaRPr lang="en-US" sz="1350" dirty="0"/>
           </a:p>
@@ -5060,7 +5060,7 @@
                   <a:srgbClr val="FFC000"/>
                 </a:solidFill>
               </a:rPr>
-              <a:t>검출 방법</a:t>
+              <a:t>Detection</a:t>
             </a:r>
             <a:endParaRPr lang="en-US" sz="1350" dirty="0"/>
           </a:p>
@@ -5096,7 +5096,7 @@
                   <a:srgbClr val="FFFFFF"/>
                 </a:solidFill>
               </a:rPr>
-              <a:t>PDGFRA IHC: amplification screening 도구로 제안</a:t>
+              <a:t>PDGFRA IHC proposed as a screening tool</a:t>
             </a:r>
             <a:endParaRPr lang="en-US" sz="1350" dirty="0"/>
           </a:p>
@@ -5132,7 +5132,7 @@
                   <a:srgbClr val="FFFFFF"/>
                 </a:solidFill>
               </a:rPr>
-              <a:t>형태학적 grade 2/3 → CNV 검사 없으면 놓침</a:t>
+              <a:t>Missed in histologic grade 2/3 tumors without CNV testing</a:t>
             </a:r>
             <a:endParaRPr lang="en-US" sz="1350" dirty="0"/>
           </a:p>
@@ -5459,7 +5459,7 @@
                   <a:srgbClr val="FFFFFF"/>
                 </a:solidFill>
               </a:rPr>
-              <a:t>ADC · rCBV에서만 aggressive feature</a:t>
+              <a:t>Aggressive features on ADC and rCBV only</a:t>
             </a:r>
             <a:endParaRPr lang="en-US" sz="1300" dirty="0"/>
           </a:p>
@@ -5499,7 +5499,7 @@
                   <a:srgbClr val="FFFFFF"/>
                 </a:solidFill>
               </a:rPr>
-              <a:t>T2-FLAIR mismatch: IDH-mut astrocytoma에 특이적, 민감도 낮음</a:t>
+              <a:t>T2-FLAIR mismatch: specific for IDH-mut astrocytoma, low sensitivity</a:t>
             </a:r>
             <a:endParaRPr lang="en-US" sz="1350" dirty="0"/>
           </a:p>
@@ -5517,7 +5517,7 @@
                   <a:srgbClr val="FFFFFF"/>
                 </a:solidFill>
               </a:rPr>
-              <a:t>주로 non-enhancing 저등급 (≥55세 cohort: G2 25%, G3/4 0%)</a:t>
+              <a:t>Mostly non-enhancing lower grade (age ≥55 cohort: G2 25%, G3/4 0%)</a:t>
             </a:r>
             <a:endParaRPr lang="en-US" sz="1350" dirty="0"/>
           </a:p>
@@ -5553,7 +5553,7 @@
                   <a:srgbClr val="FFFFFF"/>
                 </a:solidFill>
               </a:rPr>
-              <a:t>Non-enhancing high grade 존재, grade 2도 enhancement 가능</a:t>
+              <a:t>High-grade tumors can be non-enhancing; grade 2 tumors can enhance</a:t>
             </a:r>
             <a:endParaRPr lang="en-US" sz="1350" dirty="0"/>
           </a:p>
@@ -5589,7 +5589,7 @@
                   <a:srgbClr val="FFFFFF"/>
                 </a:solidFill>
               </a:rPr>
-              <a:t>Non-enhancing glioma에서 rCBV로 grade 4 구분 AUC 0.72</a:t>
+              <a:t>rCBV discriminates grade 4 in non-enhancing gliomas (AUC 0.72)</a:t>
             </a:r>
             <a:endParaRPr lang="en-US" sz="1350" dirty="0"/>
           </a:p>
@@ -5607,7 +5607,7 @@
                   <a:srgbClr val="FFFFFF"/>
                 </a:solidFill>
               </a:rPr>
-              <a:t>Biopsy target + 병리에 molecular work-up 요청 근거</a:t>
+              <a:t>Guides biopsy targeting and requests for molecular work-up</a:t>
             </a:r>
             <a:endParaRPr lang="en-US" sz="1350" dirty="0"/>
           </a:p>
@@ -5625,7 +5625,7 @@
                   <a:srgbClr val="FFFFFF"/>
                 </a:solidFill>
               </a:rPr>
-              <a:t>PDGFRA amp 특이 영상 소견: 확립된 근거 없음</a:t>
+              <a:t>No established imaging signature of PDGFRA amp</a:t>
             </a:r>
             <a:endParaRPr lang="en-US" sz="1350" dirty="0"/>
           </a:p>
@@ -5643,7 +5643,7 @@
                   <a:srgbClr val="FFFFFF"/>
                 </a:solidFill>
               </a:rPr>
-              <a:t>→ 영상-병리 불일치 시 피드백이 핵심</a:t>
+              <a:t>→ Feedback to pathology when imaging and histology disagree</a:t>
             </a:r>
             <a:endParaRPr lang="en-US" sz="1350" dirty="0"/>
           </a:p>
@@ -5956,7 +5956,7 @@
                   <a:srgbClr val="FFFFFF"/>
                 </a:solidFill>
               </a:rPr>
-              <a:t>ADC · rCBV: aggressive → 병리에 피드백</a:t>
+              <a:t>Aggressive on ADC · rCBV → feedback to pathology</a:t>
             </a:r>
             <a:endParaRPr lang="en-US" sz="1300" dirty="0"/>
           </a:p>
@@ -6072,7 +6072,7 @@
                   <a:srgbClr val="FFFFFF"/>
                 </a:solidFill>
               </a:rPr>
-              <a:t>PDGFRA amplification 확인</a:t>
+              <a:t>PDGFRA amplification detected</a:t>
             </a:r>
             <a:endParaRPr lang="en-US" sz="1300" dirty="0"/>
           </a:p>
@@ -6188,7 +6188,7 @@
                   <a:srgbClr val="FFFFFF"/>
                 </a:solidFill>
               </a:rPr>
-              <a:t>Grade 4로 재판독 (Update 12)</a:t>
+              <a:t>Regraded to grade 4 (Update 12)</a:t>
             </a:r>
             <a:endParaRPr lang="en-US" sz="1300" dirty="0"/>
           </a:p>
@@ -6304,7 +6304,7 @@
                   <a:srgbClr val="FFC000"/>
                 </a:solidFill>
               </a:rPr>
-              <a:t>CCRT 시행</a:t>
+              <a:t>Concurrent chemoradiotherapy</a:t>
             </a:r>
             <a:endParaRPr lang="en-US" sz="1300" dirty="0"/>
           </a:p>
@@ -6422,7 +6422,7 @@
                           <a:ea typeface="Calibri" pitchFamily="34" charset="-122"/>
                           <a:cs typeface="Calibri" pitchFamily="34" charset="-120"/>
                         </a:rPr>
-                        <a:t>주요 치료 근거</a:t>
+                        <a:t>Treatment evidence</a:t>
                       </a:r>
                       <a:endParaRPr lang="en-US" sz="1200" dirty="0">
                         <a:latin typeface="Calibri" charset="0"/>
@@ -6560,7 +6560,7 @@
                           <a:ea typeface="Calibri" pitchFamily="34" charset="-122"/>
                           <a:cs typeface="Calibri" pitchFamily="34" charset="-120"/>
                         </a:rPr>
-                        <a:t>관찰 (GTR) / 잔존 non-enhancing → vorasidenib (INDIGO; 식약처 2026.1 허가)</a:t>
+                        <a:t>Observation after GTR / residual non-enhancing → vorasidenib (INDIGO; MFDS approval Jan 2026)</a:t>
                       </a:r>
                       <a:endParaRPr lang="en-US" sz="1200" dirty="0">
                         <a:latin typeface="Calibri" charset="0"/>
@@ -6698,7 +6698,7 @@
                           <a:ea typeface="Calibri" pitchFamily="34" charset="-122"/>
                           <a:cs typeface="Calibri" pitchFamily="34" charset="-120"/>
                         </a:rPr>
-                        <a:t>RT → adjuvant TMZ 12 cycles (CATNON: concurrent TMZ 이득 없음)</a:t>
+                        <a:t>RT → adjuvant TMZ × 12 cycles (CATNON; no significant benefit of concurrent TMZ)</a:t>
                       </a:r>
                       <a:endParaRPr lang="en-US" sz="1200" dirty="0">
                         <a:latin typeface="Calibri" charset="0"/>
@@ -6836,7 +6836,7 @@
                           <a:ea typeface="Calibri" pitchFamily="34" charset="-122"/>
                           <a:cs typeface="Calibri" pitchFamily="34" charset="-120"/>
                         </a:rPr>
-                        <a:t>RT + TMZ, 고등급 치료 (EANO) — vorasidenib 대상 아님</a:t>
+                        <a:t>Grade 3 or GBM-type regimen (ASCO-SNO); not a vorasidenib candidate</a:t>
                       </a:r>
                       <a:endParaRPr lang="en-US" sz="1200" dirty="0">
                         <a:latin typeface="Calibri" charset="0"/>
@@ -6944,7 +6944,7 @@
                   <a:srgbClr val="FFFFFF"/>
                 </a:solidFill>
               </a:rPr>
-              <a:t>Grade = 치료 강도 · trial 적격성 · 예후 상담을 결정</a:t>
+              <a:t>Grade drives treatment intensity, trial eligibility and counseling</a:t>
             </a:r>
             <a:endParaRPr lang="en-US" sz="1350" dirty="0"/>
           </a:p>
@@ -6962,7 +6962,7 @@
                   <a:srgbClr val="FFFFFF"/>
                 </a:solidFill>
               </a:rPr>
-              <a:t>ADC/rCBV가 조직 grade보다 aggressive하면 PDGFRA · CDKN2A 등 CNV 확인 요청</a:t>
+              <a:t>If ADC/rCBV look worse than the histologic grade, ask for CNV (PDGFRA, CDKN2A/B)</a:t>
             </a:r>
             <a:endParaRPr lang="en-US" sz="1350" dirty="0"/>
           </a:p>
@@ -6980,7 +6980,7 @@
                   <a:srgbClr val="FFFFFF"/>
                 </a:solidFill>
               </a:rPr>
-              <a:t>영상 판독이 molecular upgrade의 trigger가 될 수 있음</a:t>
+              <a:t>The radiology report can trigger a molecular upgrade</a:t>
             </a:r>
             <a:endParaRPr lang="en-US" sz="1350" dirty="0"/>
           </a:p>
@@ -7019,7 +7019,7 @@
                 <a:ea typeface="Calibri" pitchFamily="34" charset="-122"/>
                 <a:cs typeface="Calibri" pitchFamily="34" charset="-120"/>
               </a:rPr>
-              <a:t>van den Bent MJ, Lancet Oncol 2021;22:813 &amp; 2026;27:45 · Mellinghoff IK, NEJM 2023;389:589 · Weller M, Nat Rev Clin Oncol 2021;18:170 · Park YW, Korean J Radiol 2026 (in press)</a:t>
+              <a:t>van den Bent MJ, Lancet Oncol 2021;22:813 &amp; 2026;27:45 · Mellinghoff IK, NEJM 2023;389:589 · Mohile NA, J Clin Oncol 2022;40:403 · Park YW, Korean J Radiol 2026 (in press)</a:t>
             </a:r>
             <a:endParaRPr lang="en-US" sz="900" dirty="0"/>
           </a:p>

</xml_diff>

<commit_message>
Update deck and study note from full text of cIMPACT-NOW Update 12
Co-Authored-By: Claude Opus 5.5 <noreply@anthropic.com>
Claude-Session: https://claude.ai/code/session_01PzFoykbWyEoGX1gUoZrhXb
</commit_message>
<xml_diff>
--- a/deck/cIMPACT-NOW_update12_disease_review.pptx
+++ b/deck/cIMPACT-NOW_update12_disease_review.pptx
@@ -602,8 +602,9 @@
               <a:t>Update 12 grading algorithm (Brat et al. 2026).
 1) Any of MVP, necrosis, CDKN2A/B HD or, newly, PDGFRA amplification → grade 4.
 2) Otherwise, mitotic count ≥3 per 2.4 mm² → grade 3; if not, grade 2.
-3) Orange box: molecular alterations that may suggest grade 3 (CDK4/6, CCND2 amp, RB1, PIK3CA/PIK3R1, EGFR, MYCN, methylation A_IDH_HG / G-CIMP-low).
-4) Oligodendroglioma: the working group found no new evidence to change grading.
+3) Orange box: Table 2 alterations. In Table 1 of the paper these are part of the grade 3 definition, so a histologic grade 2 tumor with, for example, CDK4 amplification becomes grade 3. G-CIMP-low / A_IDH_HG means at least grade 3 (classifier score &gt;0.90 required).
+4) 2.4 mm² equals 10 high-power fields of 0.24 mm². The threshold comes from Kros 2018 (455 patients from CATNON and EORTC 22033; prognostic for PFS, not OS) and Tran 2023 (100 patients). The authors say more studies are needed before WHO adopts it.
+5) Oligodendroglioma: no new grading criteria. Brisk mitoses = ≥6 per 10 HPF of 0.24 mm². Mitosis-only grade 3 tumors without MRI enhancement may do better.
 Figure redrawn from Park YW et al. Imaging of IDH-Mutant Gliomas in the Era of IDH Inhibitors: What Radiologists Need to Know. Korean J Radiol 2026 (in press), Fig. 2. Criteria from Brat et al. 2026.</a:t>
             </a:r>
             <a:endParaRPr lang="en-US" dirty="0"/>
@@ -692,12 +693,14 @@
           <a:p>
             <a:r>
               <a:rPr lang="en-US" dirty="0"/>
-              <a:t>Why PDGFRA amplification became a grade 4 criterion.
-- Validation (Richardson 2026, n=1,140): tumors reclassified to grade 4 by PDGFRA amp had median OS 51.4 months vs 126.2 months for tumors that stayed grade 3 (HR 1.9). 7 cases moved from grade 2 to 4, 15 from grade 3 to 4.
-- Yang 2019 (n=160, FISH): PDGFRA amp 18.8%, CDKN2A HD 15.0%, CDK4 amp 18.1%, mutually exclusive. Mean OS of the three risk groups: 40.5 / 62.9 / 71.5 months.
-- CATNON (Tesileanu 2021): PDGFRA amp was an independent prognostic factor in 432 IDH-mutant anaplastic astrocytomas.
-- Routine practice (Tauziede-Espariat 2026): grade changed in 12 of 50 cases (24%), including 3 grade 3 → 4.
-- Detection: NGS, methylation-array CNV, FISH; IHC proposed as a screening tool (Brain Pathol 2026).
+              <a:t>Why PDGFRA amplification became a grade 4 criterion (Update 12, p.2071 and Conclusions).
+- Rule: a grading marker needs an OS association in at least 2 independent studies, ideally with rising frequency at higher grade and at progression. Grade 4 benchmark: median OS &lt;6 years (literature 4.1-5.9).
+- Frequency: 4-6% of grade 2-3 and 8-15% of grade 4 IDH-mutant astrocytomas. Little overlap with other poor-risk markers.
+- Key evidence: CATNON, grade 3 IDH-mutant astrocytomas including CDKN2A/B-deleted cases, n=440. PDGFRA-amplified tumors: median OS 3.1 vs 9.3 years, HR 3.51 (2.21-5.58), multivariable, independent of CDKN2A/B homozygous deletion.
+- Supporting: Yang 2020 (n=155, HR 2.90), Ghosh 2025 (n=998, HR 1.9), Shirahata 2018, Richardson &amp; Walker 2020.
+- Dissent acknowledged in the paper: Virata 2026, univariable HR 4.5 but not significant on multivariable analysis.
+- After publication, Richardson 2026 (n=1,140): regraded grade 4 median OS 51.4 vs 126.2 months for tumors staying grade 3 (HR 1.9).
+- Update 12 does not define a copy-number cut-off for amplification. PDGFRA IHC (&gt;=10% strong staining) is a screening tool; confirm with FISH or CNV.
 Caveat: in the CATNON final analysis PDGFRA amp was prognostic but did not predict benefit from temozolomide.</a:t>
             </a:r>
             <a:endParaRPr lang="en-US" dirty="0"/>
@@ -787,6 +790,7 @@
             <a:r>
               <a:rPr lang="en-US" dirty="0"/>
               <a:t>(Insert the case images into the placeholders.)
+- Update 12 itself: molecular testing should be pursued when imaging shows contrast enhancement or relatively rapid progression; a slowly growing, T2-bright, non-enhancing lesion with a low-grade biopsy can be called grade 2 with fairly high confidence without advanced testing. Pre- and post-operative tumor volume and MRI growth rate are the most consistent clinical prognostic factors; the prognostic value of enhancement is disputed.
 - T2-FLAIR mismatch: high specificity, low sensitivity. In a cohort aged ≥55 it was seen in 25% of grade 2 and in no grade 3/4 tumors (Alfattal 2026). All CDKN2A HD cases were mismatch-negative (Ozono 2026).
 - Enhancement alone does not determine grade (50% of grade 2 tumors enhanced in that cohort).
 - In non-enhancing gliomas, rCBV discriminated grade 4 with AUC 0.718 (Imai 2025).
@@ -3034,7 +3038,7 @@
                           <a:ea typeface="Calibri" pitchFamily="34" charset="-122"/>
                           <a:cs typeface="Calibri" pitchFamily="34" charset="-120"/>
                         </a:rPr>
-                        <a:t>PDGFRA amp → grade 4; mitoses ≥3/2.4 mm² → grade 3; molecular markers of grade 3</a:t>
+                        <a:t>PDGFRA amp → grade 4; ≥3 mitoses/2.4 mm² or Table 2 alterations → grade 3; new subgroups</a:t>
                       </a:r>
                       <a:endParaRPr lang="en-US" sz="1150" dirty="0">
                         <a:latin typeface="Calibri" charset="0"/>
@@ -4438,7 +4442,7 @@
                   <a:srgbClr val="FFFFFF"/>
                 </a:solidFill>
               </a:rPr>
-              <a:t>Grade 2 vs 3: numeric mitotic threshold (≥3 / 2.4 mm²) and molecular markers of grade 3</a:t>
+              <a:t>Grade 3 = ≥3 mitoses / 2.4 mm² (10 HPF of 0.24 mm²) or any Table 2 molecular alteration</a:t>
             </a:r>
             <a:endParaRPr lang="en-US" sz="1400" dirty="0"/>
           </a:p>
@@ -4456,7 +4460,7 @@
                   <a:srgbClr val="FFFFFF"/>
                 </a:solidFill>
               </a:rPr>
-              <a:t>Histologic grade 2/3 tumors can be upgraded by NGS or methylation-array CNV</a:t>
+              <a:t>Mitotic cut-off rests on 2 studies; authors call for validation before WHO adoption</a:t>
             </a:r>
             <a:endParaRPr lang="en-US" sz="1400" dirty="0"/>
           </a:p>
@@ -4624,7 +4628,7 @@
                   <a:srgbClr val="FFC000"/>
                 </a:solidFill>
               </a:rPr>
-              <a:t>51 vs 126 mo</a:t>
+              <a:t>3.1 vs 9.3 yr</a:t>
             </a:r>
             <a:endParaRPr lang="en-US" sz="3000" dirty="0"/>
           </a:p>
@@ -4660,7 +4664,7 @@
                   <a:srgbClr val="FFFFFF"/>
                 </a:solidFill>
               </a:rPr>
-              <a:t>Median OS: reclassified to grade 4 by PDGFRA amp vs remaining grade 3 (HR 1.9, p=0.028)</a:t>
+              <a:t>CATNON grade 3: median OS with vs without PDGFRA amp (HR 3.51, independent of CDKN2A/B HD)</a:t>
             </a:r>
             <a:endParaRPr lang="en-US" sz="1150" dirty="0"/>
           </a:p>
@@ -4696,7 +4700,7 @@
                   <a:srgbClr val="BFBFBF"/>
                 </a:solidFill>
               </a:rPr>
-              <a:t>Richardson TE, Acta Neuropathol 2026 (n=1,140)</a:t>
+              <a:t>van den Bent, Lancet Oncol 2026 (n=440)</a:t>
             </a:r>
             <a:endParaRPr lang="en-US" sz="900" dirty="0"/>
           </a:p>
@@ -4727,14 +4731,14 @@
               <a:buNone/>
             </a:pPr>
             <a:r>
-              <a:rPr lang="en-US" sz="3000" b="1" dirty="0">
+              <a:rPr lang="en-US" sz="2400" b="1" dirty="0">
                 <a:solidFill>
                   <a:srgbClr val="FFC000"/>
                 </a:solidFill>
               </a:rPr>
-              <a:t>18.8%</a:t>
-            </a:r>
-            <a:endParaRPr lang="en-US" sz="3000" dirty="0"/>
+              <a:t>4–6% → 8–15%</a:t>
+            </a:r>
+            <a:endParaRPr lang="en-US" sz="2400" dirty="0"/>
           </a:p>
         </p:txBody>
       </p:sp>
@@ -4768,7 +4772,7 @@
                   <a:srgbClr val="FFFFFF"/>
                 </a:solidFill>
               </a:rPr>
-              <a:t>PDGFRA amp in grade 2/3 IDH-mut astrocytoma (FISH); mutually exclusive with CDKN2A HD and CDK4 amp</a:t>
+              <a:t>Frequency of PDGFRA amp: grade 2–3 vs grade 4 IDH-mut astrocytoma</a:t>
             </a:r>
             <a:endParaRPr lang="en-US" sz="1150" dirty="0"/>
           </a:p>
@@ -4804,7 +4808,7 @@
                   <a:srgbClr val="BFBFBF"/>
                 </a:solidFill>
               </a:rPr>
-              <a:t>Yang RR, Brain Pathol 2019 (n=160)</a:t>
+              <a:t>Brat DJ, Neuro-Oncol 2026 (Update 12)</a:t>
             </a:r>
             <a:endParaRPr lang="en-US" sz="900" dirty="0"/>
           </a:p>
@@ -4840,7 +4844,7 @@
                   <a:srgbClr val="FFC000"/>
                 </a:solidFill>
               </a:rPr>
-              <a:t>24%</a:t>
+              <a:t>51 vs 126 mo</a:t>
             </a:r>
             <a:endParaRPr lang="en-US" sz="3000" dirty="0"/>
           </a:p>
@@ -4876,7 +4880,7 @@
                   <a:srgbClr val="FFFFFF"/>
                 </a:solidFill>
               </a:rPr>
-              <a:t>Grade changed by molecular results in routine practice (grade 3 → 4: 3 cases)</a:t>
+              <a:t>Post-publication validation: regraded to grade 4 by PDGFRA amp vs remaining grade 3 (HR 1.9)</a:t>
             </a:r>
             <a:endParaRPr lang="en-US" sz="1150" dirty="0"/>
           </a:p>
@@ -4912,7 +4916,7 @@
                   <a:srgbClr val="BFBFBF"/>
                 </a:solidFill>
               </a:rPr>
-              <a:t>Tauziède-Espariat A, Ann Pathol 2026 (12/50)</a:t>
+              <a:t>Richardson TE, Acta Neuropathol 2026 (n=1,140)</a:t>
             </a:r>
             <a:endParaRPr lang="en-US" sz="900" dirty="0"/>
           </a:p>
@@ -4952,7 +4956,7 @@
                   <a:srgbClr val="FFC000"/>
                 </a:solidFill>
               </a:rPr>
-              <a:t>Update 12 conclusion</a:t>
+              <a:t>Update 12 rule for a grading marker</a:t>
             </a:r>
             <a:endParaRPr lang="en-US" sz="1350" dirty="0"/>
           </a:p>
@@ -4970,7 +4974,7 @@
                   <a:srgbClr val="FFFFFF"/>
                 </a:solidFill>
               </a:rPr>
-              <a:t>PDGFRA amp = highly aggressive behavior → CNS WHO grade 4</a:t>
+              <a:t>OS association in ≥2 independent studies; grade 4 = median OS &lt;6 yr</a:t>
             </a:r>
             <a:endParaRPr lang="en-US" sz="1350" dirty="0"/>
           </a:p>
@@ -4988,7 +4992,7 @@
                   <a:srgbClr val="FFC000"/>
                 </a:solidFill>
               </a:rPr>
-              <a:t>Evidence</a:t>
+              <a:t>Multivariable evidence</a:t>
             </a:r>
             <a:endParaRPr lang="en-US" sz="1350" dirty="0"/>
           </a:p>
@@ -5006,7 +5010,25 @@
                   <a:srgbClr val="FFFFFF"/>
                 </a:solidFill>
               </a:rPr>
-              <a:t>Yang 2019: PDGFRA amp = highest-risk group (mean OS 40.5 vs 71.5 mo)</a:t>
+              <a:t>CATNON HR 3.51 · Yang 2020 HR 2.90 (n=155) · Ghosh 2025 HR 1.9 (n=998)</a:t>
+            </a:r>
+            <a:endParaRPr lang="en-US" sz="1350" dirty="0"/>
+          </a:p>
+          <a:p>
+            <a:pPr marL="177800" indent="-177800">
+              <a:spcAft>
+                <a:spcPts val="300"/>
+              </a:spcAft>
+              <a:buSzPct val="100000"/>
+              <a:buChar char="•"/>
+            </a:pPr>
+            <a:r>
+              <a:rPr lang="en-US" sz="1350" b="1" dirty="0">
+                <a:solidFill>
+                  <a:srgbClr val="FFC000"/>
+                </a:solidFill>
+              </a:rPr>
+              <a:t>Dissent</a:t>
             </a:r>
             <a:endParaRPr lang="en-US" sz="1350" dirty="0"/>
           </a:p>
@@ -5024,7 +5046,25 @@
                   <a:srgbClr val="FFFFFF"/>
                 </a:solidFill>
               </a:rPr>
-              <a:t>CATNON (432 IDH-mut anaplastic astrocytomas): independent prognostic factor</a:t>
+              <a:t>Virata 2026: univariable HR 4.5, not significant on multivariable</a:t>
+            </a:r>
+            <a:endParaRPr lang="en-US" sz="1350" dirty="0"/>
+          </a:p>
+          <a:p>
+            <a:pPr marL="177800" indent="-177800">
+              <a:spcAft>
+                <a:spcPts val="300"/>
+              </a:spcAft>
+              <a:buSzPct val="100000"/>
+              <a:buChar char="•"/>
+            </a:pPr>
+            <a:r>
+              <a:rPr lang="en-US" sz="1350" b="1" dirty="0">
+                <a:solidFill>
+                  <a:srgbClr val="FFC000"/>
+                </a:solidFill>
+              </a:rPr>
+              <a:t>Detection</a:t>
             </a:r>
             <a:endParaRPr lang="en-US" sz="1350" dirty="0"/>
           </a:p>
@@ -5042,7 +5082,25 @@
                   <a:srgbClr val="FFFFFF"/>
                 </a:solidFill>
               </a:rPr>
-              <a:t>Virata 2026: grade 2/3 with these alterations, median OS 67–82 vs 135–141 mo</a:t>
+              <a:t>NGS, methylation-array CNV, FISH, SNP/CGH array; IHC for screening</a:t>
+            </a:r>
+            <a:endParaRPr lang="en-US" sz="1350" dirty="0"/>
+          </a:p>
+          <a:p>
+            <a:pPr lvl="1" marL="355600" indent="-177800">
+              <a:spcAft>
+                <a:spcPts val="300"/>
+              </a:spcAft>
+              <a:buSzPct val="100000"/>
+              <a:buChar char="•"/>
+            </a:pPr>
+            <a:r>
+              <a:rPr lang="en-US" sz="1350" dirty="0">
+                <a:solidFill>
+                  <a:srgbClr val="FFFFFF"/>
+                </a:solidFill>
+              </a:rPr>
+              <a:t>No copy-number cut-off defined in Update 12</a:t>
             </a:r>
             <a:endParaRPr lang="en-US" sz="1350" dirty="0"/>
           </a:p>
@@ -5060,7 +5118,7 @@
                   <a:srgbClr val="FFC000"/>
                 </a:solidFill>
               </a:rPr>
-              <a:t>Detection</a:t>
+              <a:t>Pitfall</a:t>
             </a:r>
             <a:endParaRPr lang="en-US" sz="1350" dirty="0"/>
           </a:p>
@@ -5078,60 +5136,6 @@
                   <a:srgbClr val="FFFFFF"/>
                 </a:solidFill>
               </a:rPr>
-              <a:t>NGS CNV, methylation array CNV, FISH, SNP/CGH array</a:t>
-            </a:r>
-            <a:endParaRPr lang="en-US" sz="1350" dirty="0"/>
-          </a:p>
-          <a:p>
-            <a:pPr lvl="1" marL="355600" indent="-177800">
-              <a:spcAft>
-                <a:spcPts val="300"/>
-              </a:spcAft>
-              <a:buSzPct val="100000"/>
-              <a:buChar char="•"/>
-            </a:pPr>
-            <a:r>
-              <a:rPr lang="en-US" sz="1350" dirty="0">
-                <a:solidFill>
-                  <a:srgbClr val="FFFFFF"/>
-                </a:solidFill>
-              </a:rPr>
-              <a:t>PDGFRA IHC proposed as a screening tool</a:t>
-            </a:r>
-            <a:endParaRPr lang="en-US" sz="1350" dirty="0"/>
-          </a:p>
-          <a:p>
-            <a:pPr marL="177800" indent="-177800">
-              <a:spcAft>
-                <a:spcPts val="300"/>
-              </a:spcAft>
-              <a:buSzPct val="100000"/>
-              <a:buChar char="•"/>
-            </a:pPr>
-            <a:r>
-              <a:rPr lang="en-US" sz="1350" b="1" dirty="0">
-                <a:solidFill>
-                  <a:srgbClr val="FFC000"/>
-                </a:solidFill>
-              </a:rPr>
-              <a:t>Pitfall</a:t>
-            </a:r>
-            <a:endParaRPr lang="en-US" sz="1350" dirty="0"/>
-          </a:p>
-          <a:p>
-            <a:pPr lvl="1" marL="355600" indent="-177800">
-              <a:spcAft>
-                <a:spcPts val="300"/>
-              </a:spcAft>
-              <a:buSzPct val="100000"/>
-              <a:buChar char="•"/>
-            </a:pPr>
-            <a:r>
-              <a:rPr lang="en-US" sz="1350" dirty="0">
-                <a:solidFill>
-                  <a:srgbClr val="FFFFFF"/>
-                </a:solidFill>
-              </a:rPr>
               <a:t>Missed in histologic grade 2/3 tumors without CNV testing</a:t>
             </a:r>
             <a:endParaRPr lang="en-US" sz="1350" dirty="0"/>
@@ -5171,7 +5175,7 @@
                 <a:ea typeface="Calibri" pitchFamily="34" charset="-122"/>
                 <a:cs typeface="Calibri" pitchFamily="34" charset="-120"/>
               </a:rPr>
-              <a:t>Brat DJ, Neuro-Oncol 2026 · Richardson TE, Acta Neuropathol 2026;152 · Yang RR, Brain Pathol 2019 · Tesileanu CMS, Neuro-Oncol 2021 · Virata MC, Neuro-Oncol 2026 · Tauziède-Espariat A, Brain Pathol 2026;e70142</a:t>
+              <a:t>Brat DJ, Neuro-Oncol 2026;28:2069 · van den Bent MJ, Lancet Oncol 2026;27:45 · Yang RR, Brain Pathol 2020;30:541 · Ghosh HS, Neuro-Oncol 2025;27:993 · Virata MC, Neuro-Oncol 2026 · Richardson TE, Acta Neuropathol 2026</a:t>
             </a:r>
             <a:endParaRPr lang="en-US" sz="900" dirty="0"/>
           </a:p>
@@ -5494,14 +5498,14 @@
               <a:buChar char="•"/>
             </a:pPr>
             <a:r>
-              <a:rPr lang="en-US" sz="1350" b="1" dirty="0">
-                <a:solidFill>
-                  <a:srgbClr val="FFFFFF"/>
-                </a:solidFill>
-              </a:rPr>
-              <a:t>T2-FLAIR mismatch: specific for IDH-mut astrocytoma, low sensitivity</a:t>
-            </a:r>
-            <a:endParaRPr lang="en-US" sz="1350" dirty="0"/>
+              <a:rPr lang="en-US" sz="1300" b="1" dirty="0">
+                <a:solidFill>
+                  <a:srgbClr val="FFC000"/>
+                </a:solidFill>
+              </a:rPr>
+              <a:t>Update 12 on imaging</a:t>
+            </a:r>
+            <a:endParaRPr lang="en-US" sz="1300" dirty="0"/>
           </a:p>
           <a:p>
             <a:pPr lvl="1" marL="355600" indent="-177800">
@@ -5512,14 +5516,50 @@
               <a:buChar char="•"/>
             </a:pPr>
             <a:r>
-              <a:rPr lang="en-US" sz="1350" dirty="0">
+              <a:rPr lang="en-US" sz="1300" dirty="0">
                 <a:solidFill>
                   <a:srgbClr val="FFFFFF"/>
                 </a:solidFill>
               </a:rPr>
-              <a:t>Mostly non-enhancing lower grade (age ≥55 cohort: G2 25%, G3/4 0%)</a:t>
-            </a:r>
-            <a:endParaRPr lang="en-US" sz="1350" dirty="0"/>
+              <a:t>Enhancement or rapid growth → molecular testing</a:t>
+            </a:r>
+            <a:endParaRPr lang="en-US" sz="1300" dirty="0"/>
+          </a:p>
+          <a:p>
+            <a:pPr lvl="1" marL="355600" indent="-177800">
+              <a:spcAft>
+                <a:spcPts val="400"/>
+              </a:spcAft>
+              <a:buSzPct val="100000"/>
+              <a:buChar char="•"/>
+            </a:pPr>
+            <a:r>
+              <a:rPr lang="en-US" sz="1300" dirty="0">
+                <a:solidFill>
+                  <a:srgbClr val="FFFFFF"/>
+                </a:solidFill>
+              </a:rPr>
+              <a:t>Slow-growing, T2-bright, non-enhancing + low-grade biopsy → grade 2 with fair confidence</a:t>
+            </a:r>
+            <a:endParaRPr lang="en-US" sz="1300" dirty="0"/>
+          </a:p>
+          <a:p>
+            <a:pPr lvl="1" marL="355600" indent="-177800">
+              <a:spcAft>
+                <a:spcPts val="400"/>
+              </a:spcAft>
+              <a:buSzPct val="100000"/>
+              <a:buChar char="•"/>
+            </a:pPr>
+            <a:r>
+              <a:rPr lang="en-US" sz="1300" dirty="0">
+                <a:solidFill>
+                  <a:srgbClr val="FFFFFF"/>
+                </a:solidFill>
+              </a:rPr>
+              <a:t>Pre-/post-op tumor size: most consistent prognostic factor</a:t>
+            </a:r>
+            <a:endParaRPr lang="en-US" sz="1300" dirty="0"/>
           </a:p>
           <a:p>
             <a:pPr marL="177800" indent="-177800">
@@ -5530,14 +5570,14 @@
               <a:buChar char="•"/>
             </a:pPr>
             <a:r>
-              <a:rPr lang="en-US" sz="1350" b="1" dirty="0">
+              <a:rPr lang="en-US" sz="1300" b="1" dirty="0">
                 <a:solidFill>
                   <a:srgbClr val="FFFFFF"/>
                 </a:solidFill>
               </a:rPr>
-              <a:t>Enhancement ≠ grade</a:t>
-            </a:r>
-            <a:endParaRPr lang="en-US" sz="1350" dirty="0"/>
+              <a:t>T2-FLAIR mismatch: specific, low sensitivity</a:t>
+            </a:r>
+            <a:endParaRPr lang="en-US" sz="1300" dirty="0"/>
           </a:p>
           <a:p>
             <a:pPr lvl="1" marL="355600" indent="-177800">
@@ -5548,14 +5588,14 @@
               <a:buChar char="•"/>
             </a:pPr>
             <a:r>
-              <a:rPr lang="en-US" sz="1350" dirty="0">
+              <a:rPr lang="en-US" sz="1300" dirty="0">
                 <a:solidFill>
                   <a:srgbClr val="FFFFFF"/>
                 </a:solidFill>
               </a:rPr>
-              <a:t>High-grade tumors can be non-enhancing; grade 2 tumors can enhance</a:t>
-            </a:r>
-            <a:endParaRPr lang="en-US" sz="1350" dirty="0"/>
+              <a:t>Absent in all CDKN2A/B-deleted tumors (n=5)</a:t>
+            </a:r>
+            <a:endParaRPr lang="en-US" sz="1300" dirty="0"/>
           </a:p>
           <a:p>
             <a:pPr marL="177800" indent="-177800">
@@ -5566,14 +5606,14 @@
               <a:buChar char="•"/>
             </a:pPr>
             <a:r>
-              <a:rPr lang="en-US" sz="1350" b="1" dirty="0">
+              <a:rPr lang="en-US" sz="1300" b="1" dirty="0">
                 <a:solidFill>
                   <a:srgbClr val="FFC000"/>
                 </a:solidFill>
               </a:rPr>
               <a:t>ADC ↓ / rCBV ↑ focus</a:t>
             </a:r>
-            <a:endParaRPr lang="en-US" sz="1350" dirty="0"/>
+            <a:endParaRPr lang="en-US" sz="1300" dirty="0"/>
           </a:p>
           <a:p>
             <a:pPr lvl="1" marL="355600" indent="-177800">
@@ -5584,14 +5624,32 @@
               <a:buChar char="•"/>
             </a:pPr>
             <a:r>
-              <a:rPr lang="en-US" sz="1350" dirty="0">
+              <a:rPr lang="en-US" sz="1300" dirty="0">
                 <a:solidFill>
                   <a:srgbClr val="FFFFFF"/>
                 </a:solidFill>
               </a:rPr>
-              <a:t>rCBV discriminates grade 4 in non-enhancing gliomas (AUC 0.72)</a:t>
-            </a:r>
-            <a:endParaRPr lang="en-US" sz="1350" dirty="0"/>
+              <a:t>rCBV separates grade 4 in non-enhancing gliomas (AUC 0.72); biopsy target</a:t>
+            </a:r>
+            <a:endParaRPr lang="en-US" sz="1300" dirty="0"/>
+          </a:p>
+          <a:p>
+            <a:pPr marL="177800" indent="-177800">
+              <a:spcAft>
+                <a:spcPts val="400"/>
+              </a:spcAft>
+              <a:buSzPct val="100000"/>
+              <a:buChar char="•"/>
+            </a:pPr>
+            <a:r>
+              <a:rPr lang="en-US" sz="1300" b="1" dirty="0">
+                <a:solidFill>
+                  <a:srgbClr val="FFFFFF"/>
+                </a:solidFill>
+              </a:rPr>
+              <a:t>No imaging signature of PDGFRA amp</a:t>
+            </a:r>
+            <a:endParaRPr lang="en-US" sz="1300" dirty="0"/>
           </a:p>
           <a:p>
             <a:pPr lvl="1" marL="355600" indent="-177800">
@@ -5602,50 +5660,14 @@
               <a:buChar char="•"/>
             </a:pPr>
             <a:r>
-              <a:rPr lang="en-US" sz="1350" dirty="0">
+              <a:rPr lang="en-US" sz="1300" dirty="0">
                 <a:solidFill>
                   <a:srgbClr val="FFFFFF"/>
                 </a:solidFill>
               </a:rPr>
-              <a:t>Guides biopsy targeting and requests for molecular work-up</a:t>
-            </a:r>
-            <a:endParaRPr lang="en-US" sz="1350" dirty="0"/>
-          </a:p>
-          <a:p>
-            <a:pPr marL="177800" indent="-177800">
-              <a:spcAft>
-                <a:spcPts val="400"/>
-              </a:spcAft>
-              <a:buSzPct val="100000"/>
-              <a:buChar char="•"/>
-            </a:pPr>
-            <a:r>
-              <a:rPr lang="en-US" sz="1350" b="1" dirty="0">
-                <a:solidFill>
-                  <a:srgbClr val="FFFFFF"/>
-                </a:solidFill>
-              </a:rPr>
-              <a:t>No established imaging signature of PDGFRA amp</a:t>
-            </a:r>
-            <a:endParaRPr lang="en-US" sz="1350" dirty="0"/>
-          </a:p>
-          <a:p>
-            <a:pPr lvl="1" marL="355600" indent="-177800">
-              <a:spcAft>
-                <a:spcPts val="400"/>
-              </a:spcAft>
-              <a:buSzPct val="100000"/>
-              <a:buChar char="•"/>
-            </a:pPr>
-            <a:r>
-              <a:rPr lang="en-US" sz="1350" dirty="0">
-                <a:solidFill>
-                  <a:srgbClr val="FFFFFF"/>
-                </a:solidFill>
-              </a:rPr>
               <a:t>→ Feedback to pathology when imaging and histology disagree</a:t>
             </a:r>
-            <a:endParaRPr lang="en-US" sz="1350" dirty="0"/>
+            <a:endParaRPr lang="en-US" sz="1300" dirty="0"/>
           </a:p>
         </p:txBody>
       </p:sp>
@@ -5682,7 +5704,7 @@
                 <a:ea typeface="Calibri" pitchFamily="34" charset="-122"/>
                 <a:cs typeface="Calibri" pitchFamily="34" charset="-120"/>
               </a:rPr>
-              <a:t>Alfattal, Int J Surg Pathol 2026 · Ozono, J Neurooncol 2026 · Imai, J Clin Med 2025;14:6777 · Yang, AJNR 2025 · Kurokawa, Jpn J Radiol 2026;44:1534</a:t>
+              <a:t>Brat DJ, Neuro-Oncol 2026 (Fig. 1, Conclusions) · Ozono, J Neurooncol 2026 · Imai, J Clin Med 2025;14:6777 · Kurokawa, Jpn J Radiol 2026;44:1534</a:t>
             </a:r>
             <a:endParaRPr lang="en-US" sz="900" dirty="0"/>
           </a:p>

</xml_diff>